<commit_message>
Document the freeze/fine-tune rationale in the report and deck
Explains why only MobileNetV2's last block + new classifier are
trainable (everything else frozen at ImageNet weights): overfitting
risk on 176 images vs. 3.4M parameters, early/mid layers already being
general-purpose, only the last block being task-specific enough to be
worth adapting, and training-time compute across 17 configs. Added to
Workflow.md SS5 (Decisions) and mirrored as a sub-bullet on the deck's
Preprocessing & Modeling Approach slide.

Also notes this is a dataset-size-driven choice, not a ceiling --
added "unfreeze more of the backbone" to the full-scale-pilot roadmap
(SS16.3 and the deck's Further Directions slide), alongside the
existing "retrain on a larger database" item.
</commit_message>
<xml_diff>
--- a/Evaluation & Docs/Final Presentation.pptx
+++ b/Evaluation & Docs/Final Presentation.pptx
@@ -6111,13 +6111,13 @@
               </a:spcAft>
             </a:pPr>
             <a:r>
-              <a:rPr sz="1500">
+              <a:rPr sz="1400">
                 <a:solidFill>
                   <a:srgbClr val="222833"/>
                 </a:solidFill>
                 <a:latin typeface="Calibri"/>
               </a:rPr>
-              <a:t>▪  Retrain on a much larger database once IT/data-access constraints are lifted.</a:t>
+              <a:t>▪  Retrain on a much larger database once IT/data-access constraints are lifted, and unfreeze more of the backbone (today's last-block-only fine-tuning is a dataset-size-driven choice, not a ceiling).</a:t>
             </a:r>
           </a:p>
           <a:p>
@@ -6130,7 +6130,7 @@
               </a:spcAft>
             </a:pPr>
             <a:r>
-              <a:rPr sz="1500">
+              <a:rPr sz="1400">
                 <a:solidFill>
                   <a:srgbClr val="222833"/>
                 </a:solidFill>
@@ -6149,7 +6149,7 @@
               </a:spcAft>
             </a:pPr>
             <a:r>
-              <a:rPr sz="1500">
+              <a:rPr sz="1400">
                 <a:solidFill>
                   <a:srgbClr val="222833"/>
                 </a:solidFill>
@@ -6168,7 +6168,7 @@
               </a:spcAft>
             </a:pPr>
             <a:r>
-              <a:rPr sz="1500">
+              <a:rPr sz="1400">
                 <a:solidFill>
                   <a:srgbClr val="222833"/>
                 </a:solidFill>
@@ -6187,7 +6187,7 @@
               </a:spcAft>
             </a:pPr>
             <a:r>
-              <a:rPr sz="1500">
+              <a:rPr sz="1400">
                 <a:solidFill>
                   <a:srgbClr val="222833"/>
                 </a:solidFill>
@@ -8971,7 +8971,26 @@
                 </a:solidFill>
                 <a:latin typeface="Calibri"/>
               </a:rPr>
-              <a:t>▪  Model: MobileNetV2 (ImageNet-pretrained), last block fine-tuned, rest frozen — transfer learning, not training from scratch (§1.1).</a:t>
+              <a:t>▪  Model: MobileNetV2 (52 conv layers, ImageNet-pretrained) — transfer learning, not training from scratch (§1.1).</a:t>
+            </a:r>
+          </a:p>
+          <a:p>
+            <a:pPr>
+              <a:lnSpc>
+                <a:spcPct val="115000"/>
+              </a:lnSpc>
+              <a:spcAft>
+                <a:spcPts val="800"/>
+              </a:spcAft>
+            </a:pPr>
+            <a:r>
+              <a:rPr sz="1500">
+                <a:solidFill>
+                  <a:srgbClr val="5A6370"/>
+                </a:solidFill>
+                <a:latin typeface="Calibri"/>
+              </a:rPr>
+              <a:t>    – Only the last block + new classifier are unfrozen; the rest stays at pretrained weights — 176 images can't support fully fine-tuning 3.4M parameters without overfitting. A larger database would support unfreezing more (§16.3).</a:t>
             </a:r>
           </a:p>
           <a:p>

</xml_diff>